<commit_message>
Ask before building, record software demos, integrate animated slides in the pptx
- Skill: intake questions first (what to get, HTML or pptx, audience, message), answers kept in brief.md.
- docs/software-demos(.es).md: 20 recognized demos and studies on showing software, with verification status.
- kit.py demo + engine/demo.py: demo videos recorded from the real running app (zoom, cursor, captions,
  mock-up stamp, cut waits marked); @video key; V key; example examples/software-demo.
- pptx: full-bleed animated slides use their final frame as the slide background with the text on top,
  kicker included; cover text placed clear of the figure.

Co-Authored-By: Claude Opus 5.5 <noreply@anthropic.com>
</commit_message>
<xml_diff>
--- a/examples/exoplanets/exoplanets.es.pptx
+++ b/examples/exoplanets/exoplanets.es.pptx
@@ -3943,15 +3943,39 @@
         <p:nvPr/>
       </p:nvGrpSpPr>
       <p:grpSpPr/>
-      <p:sp>
-        <p:nvSpPr>
-          <p:cNvPr id="2" name="TextBox 1"/>
+      <p:pic>
+        <p:nvPicPr>
+          <p:cNvPr id="3" name="Picture 2" descr="static_cover.es.png"/>
+          <p:cNvPicPr>
+            <a:picLocks noChangeAspect="1"/>
+          </p:cNvPicPr>
+          <p:nvPr/>
+        </p:nvPicPr>
+        <p:blipFill>
+          <a:blip r:embed="rId2"/>
+          <a:stretch>
+            <a:fillRect/>
+          </a:stretch>
+        </p:blipFill>
+        <p:spPr>
+          <a:xfrm>
+            <a:off x="0" y="0"/>
+            <a:ext cx="12192000" cy="6858000"/>
+          </a:xfrm>
+          <a:prstGeom prst="rect">
+            <a:avLst/>
+          </a:prstGeom>
+        </p:spPr>
+      </p:pic>
+      <p:sp>
+        <p:nvSpPr>
+          <p:cNvPr id="4" name="TextBox 3"/>
           <p:cNvSpPr txBox="1"/>
           <p:nvPr/>
         </p:nvSpPr>
         <p:spPr>
           <a:xfrm>
-            <a:off x="762000" y="2057400"/>
+            <a:off x="762000" y="822960"/>
             <a:ext cx="10668000" cy="1905000"/>
           </a:xfrm>
           <a:prstGeom prst="rect">
@@ -3984,13 +4008,13 @@
       </p:sp>
       <p:sp>
         <p:nvSpPr>
-          <p:cNvPr id="3" name="TextBox 2"/>
+          <p:cNvPr id="5" name="TextBox 4"/>
           <p:cNvSpPr txBox="1"/>
           <p:nvPr/>
         </p:nvSpPr>
         <p:spPr>
           <a:xfrm>
-            <a:off x="762000" y="4152900"/>
+            <a:off x="762000" y="2664460"/>
             <a:ext cx="10668000" cy="762000"/>
           </a:xfrm>
           <a:prstGeom prst="rect">
@@ -4012,7 +4036,7 @@
             <a:r>
               <a:rPr sz="2000" b="0">
                 <a:solidFill>
-                  <a:srgbClr val="9AA8BA"/>
+                  <a:srgbClr val="F5A623"/>
                 </a:solidFill>
                 <a:latin typeface="Calibri"/>
               </a:rPr>
@@ -4023,13 +4047,13 @@
       </p:sp>
       <p:sp>
         <p:nvSpPr>
-          <p:cNvPr id="4" name="TextBox 3"/>
+          <p:cNvPr id="6" name="TextBox 5"/>
           <p:cNvSpPr txBox="1"/>
           <p:nvPr/>
         </p:nvSpPr>
         <p:spPr>
           <a:xfrm>
-            <a:off x="762000" y="5349240"/>
+            <a:off x="762000" y="3426460"/>
             <a:ext cx="10668000" cy="381000"/>
           </a:xfrm>
           <a:prstGeom prst="rect">
@@ -4086,45 +4110,6 @@
         <p:nvPr/>
       </p:nvGrpSpPr>
       <p:grpSpPr/>
-      <p:sp>
-        <p:nvSpPr>
-          <p:cNvPr id="2" name="TextBox 1"/>
-          <p:cNvSpPr txBox="1"/>
-          <p:nvPr/>
-        </p:nvSpPr>
-        <p:spPr>
-          <a:xfrm>
-            <a:off x="762000" y="571500"/>
-            <a:ext cx="10668000" cy="952500"/>
-          </a:xfrm>
-          <a:prstGeom prst="rect">
-            <a:avLst/>
-          </a:prstGeom>
-          <a:noFill/>
-        </p:spPr>
-        <p:txBody>
-          <a:bodyPr wrap="square">
-            <a:spAutoFit/>
-          </a:bodyPr>
-          <a:lstStyle/>
-          <a:p>
-            <a:pPr>
-              <a:spcAft>
-                <a:spcPts val="1800"/>
-              </a:spcAft>
-            </a:pPr>
-            <a:r>
-              <a:rPr sz="3000" b="1">
-                <a:solidFill>
-                  <a:srgbClr val="EEF2F7"/>
-                </a:solidFill>
-                <a:latin typeface="Cambria"/>
-              </a:rPr>
-              <a:t>Cuando un planeta pasa por delante, su estrella se apaga un poco</a:t>
-            </a:r>
-          </a:p>
-        </p:txBody>
-      </p:sp>
       <p:pic>
         <p:nvPicPr>
           <p:cNvPr id="3" name="Picture 2" descr="static_transit.es.png"/>
@@ -4141,8 +4126,8 @@
         </p:blipFill>
         <p:spPr>
           <a:xfrm>
-            <a:off x="2144889" y="1714500"/>
-            <a:ext cx="7902222" cy="4445000"/>
+            <a:off x="0" y="0"/>
+            <a:ext cx="12192000" cy="6858000"/>
           </a:xfrm>
           <a:prstGeom prst="rect">
             <a:avLst/>
@@ -4152,6 +4137,108 @@
       <p:sp>
         <p:nvSpPr>
           <p:cNvPr id="4" name="TextBox 3"/>
+          <p:cNvSpPr txBox="1"/>
+          <p:nvPr/>
+        </p:nvSpPr>
+        <p:spPr>
+          <a:xfrm>
+            <a:off x="762000" y="444500"/>
+            <a:ext cx="10668000" cy="254000"/>
+          </a:xfrm>
+          <a:prstGeom prst="rect">
+            <a:avLst/>
+          </a:prstGeom>
+          <a:noFill/>
+        </p:spPr>
+        <p:txBody>
+          <a:bodyPr wrap="square">
+            <a:spAutoFit/>
+          </a:bodyPr>
+          <a:lstStyle/>
+          <a:p>
+            <a:pPr>
+              <a:spcAft>
+                <a:spcPts val="660"/>
+              </a:spcAft>
+            </a:pPr>
+            <a:r>
+              <a:rPr sz="1100" b="0">
+                <a:solidFill>
+                  <a:srgbClr val="F5A623"/>
+                </a:solidFill>
+                <a:latin typeface="Calibri"/>
+              </a:rPr>
+              <a:t>LA SOMBRA</a:t>
+            </a:r>
+          </a:p>
+        </p:txBody>
+      </p:sp>
+      <p:sp>
+        <p:nvSpPr>
+          <p:cNvPr id="5" name="TextBox 4"/>
+          <p:cNvSpPr txBox="1"/>
+          <p:nvPr/>
+        </p:nvSpPr>
+        <p:spPr>
+          <a:xfrm>
+            <a:off x="762000" y="762000"/>
+            <a:ext cx="10668000" cy="952500"/>
+          </a:xfrm>
+          <a:prstGeom prst="rect">
+            <a:avLst/>
+          </a:prstGeom>
+          <a:noFill/>
+        </p:spPr>
+        <p:txBody>
+          <a:bodyPr wrap="square">
+            <a:spAutoFit/>
+          </a:bodyPr>
+          <a:lstStyle/>
+          <a:p>
+            <a:pPr>
+              <a:spcAft>
+                <a:spcPts val="1800"/>
+              </a:spcAft>
+            </a:pPr>
+            <a:r>
+              <a:rPr sz="3000" b="1">
+                <a:solidFill>
+                  <a:srgbClr val="EEF2F7"/>
+                </a:solidFill>
+                <a:latin typeface="Cambria"/>
+              </a:rPr>
+              <a:t>Cuando un planeta pasa por delante, su estrella se apaga un poco</a:t>
+            </a:r>
+          </a:p>
+        </p:txBody>
+      </p:sp>
+      <p:sp>
+        <p:nvSpPr>
+          <p:cNvPr id="6" name="TextBox 5"/>
+          <p:cNvSpPr txBox="1"/>
+          <p:nvPr/>
+        </p:nvSpPr>
+        <p:spPr>
+          <a:xfrm>
+            <a:off x="762000" y="1714500"/>
+            <a:ext cx="10668000" cy="4445000"/>
+          </a:xfrm>
+          <a:prstGeom prst="rect">
+            <a:avLst/>
+          </a:prstGeom>
+          <a:noFill/>
+        </p:spPr>
+        <p:txBody>
+          <a:bodyPr wrap="square" anchor="ctr">
+            <a:spAutoFit/>
+          </a:bodyPr>
+          <a:lstStyle/>
+          <a:p/>
+        </p:txBody>
+      </p:sp>
+      <p:sp>
+        <p:nvSpPr>
+          <p:cNvPr id="7" name="TextBox 6"/>
           <p:cNvSpPr txBox="1"/>
           <p:nvPr/>
         </p:nvSpPr>
@@ -4214,45 +4301,6 @@
         <p:nvPr/>
       </p:nvGrpSpPr>
       <p:grpSpPr/>
-      <p:sp>
-        <p:nvSpPr>
-          <p:cNvPr id="2" name="TextBox 1"/>
-          <p:cNvSpPr txBox="1"/>
-          <p:nvPr/>
-        </p:nvSpPr>
-        <p:spPr>
-          <a:xfrm>
-            <a:off x="762000" y="571500"/>
-            <a:ext cx="10668000" cy="952500"/>
-          </a:xfrm>
-          <a:prstGeom prst="rect">
-            <a:avLst/>
-          </a:prstGeom>
-          <a:noFill/>
-        </p:spPr>
-        <p:txBody>
-          <a:bodyPr wrap="square">
-            <a:spAutoFit/>
-          </a:bodyPr>
-          <a:lstStyle/>
-          <a:p>
-            <a:pPr>
-              <a:spcAft>
-                <a:spcPts val="1800"/>
-              </a:spcAft>
-            </a:pPr>
-            <a:r>
-              <a:rPr sz="3000" b="1">
-                <a:solidFill>
-                  <a:srgbClr val="EEF2F7"/>
-                </a:solidFill>
-                <a:latin typeface="Cambria"/>
-              </a:rPr>
-              <a:t>La estrella también se mece: la Tierra mueve al Sol apenas 9 cm/s</a:t>
-            </a:r>
-          </a:p>
-        </p:txBody>
-      </p:sp>
       <p:pic>
         <p:nvPicPr>
           <p:cNvPr id="3" name="Picture 2" descr="static_orbit.es.png"/>
@@ -4269,8 +4317,8 @@
         </p:blipFill>
         <p:spPr>
           <a:xfrm>
-            <a:off x="2144889" y="1714500"/>
-            <a:ext cx="7902222" cy="4445000"/>
+            <a:off x="0" y="0"/>
+            <a:ext cx="12192000" cy="6858000"/>
           </a:xfrm>
           <a:prstGeom prst="rect">
             <a:avLst/>
@@ -4280,6 +4328,108 @@
       <p:sp>
         <p:nvSpPr>
           <p:cNvPr id="4" name="TextBox 3"/>
+          <p:cNvSpPr txBox="1"/>
+          <p:nvPr/>
+        </p:nvSpPr>
+        <p:spPr>
+          <a:xfrm>
+            <a:off x="762000" y="444500"/>
+            <a:ext cx="10668000" cy="254000"/>
+          </a:xfrm>
+          <a:prstGeom prst="rect">
+            <a:avLst/>
+          </a:prstGeom>
+          <a:noFill/>
+        </p:spPr>
+        <p:txBody>
+          <a:bodyPr wrap="square">
+            <a:spAutoFit/>
+          </a:bodyPr>
+          <a:lstStyle/>
+          <a:p>
+            <a:pPr>
+              <a:spcAft>
+                <a:spcPts val="660"/>
+              </a:spcAft>
+            </a:pPr>
+            <a:r>
+              <a:rPr sz="1100" b="0">
+                <a:solidFill>
+                  <a:srgbClr val="F5A623"/>
+                </a:solidFill>
+                <a:latin typeface="Calibri"/>
+              </a:rPr>
+              <a:t>EL BAMBOLEO</a:t>
+            </a:r>
+          </a:p>
+        </p:txBody>
+      </p:sp>
+      <p:sp>
+        <p:nvSpPr>
+          <p:cNvPr id="5" name="TextBox 4"/>
+          <p:cNvSpPr txBox="1"/>
+          <p:nvPr/>
+        </p:nvSpPr>
+        <p:spPr>
+          <a:xfrm>
+            <a:off x="762000" y="762000"/>
+            <a:ext cx="10668000" cy="952500"/>
+          </a:xfrm>
+          <a:prstGeom prst="rect">
+            <a:avLst/>
+          </a:prstGeom>
+          <a:noFill/>
+        </p:spPr>
+        <p:txBody>
+          <a:bodyPr wrap="square">
+            <a:spAutoFit/>
+          </a:bodyPr>
+          <a:lstStyle/>
+          <a:p>
+            <a:pPr>
+              <a:spcAft>
+                <a:spcPts val="1800"/>
+              </a:spcAft>
+            </a:pPr>
+            <a:r>
+              <a:rPr sz="3000" b="1">
+                <a:solidFill>
+                  <a:srgbClr val="EEF2F7"/>
+                </a:solidFill>
+                <a:latin typeface="Cambria"/>
+              </a:rPr>
+              <a:t>La estrella también se mece: la Tierra mueve al Sol apenas 9 cm/s</a:t>
+            </a:r>
+          </a:p>
+        </p:txBody>
+      </p:sp>
+      <p:sp>
+        <p:nvSpPr>
+          <p:cNvPr id="6" name="TextBox 5"/>
+          <p:cNvSpPr txBox="1"/>
+          <p:nvPr/>
+        </p:nvSpPr>
+        <p:spPr>
+          <a:xfrm>
+            <a:off x="762000" y="1714500"/>
+            <a:ext cx="10668000" cy="4445000"/>
+          </a:xfrm>
+          <a:prstGeom prst="rect">
+            <a:avLst/>
+          </a:prstGeom>
+          <a:noFill/>
+        </p:spPr>
+        <p:txBody>
+          <a:bodyPr wrap="square" anchor="ctr">
+            <a:spAutoFit/>
+          </a:bodyPr>
+          <a:lstStyle/>
+          <a:p/>
+        </p:txBody>
+      </p:sp>
+      <p:sp>
+        <p:nvSpPr>
+          <p:cNvPr id="7" name="TextBox 6"/>
           <p:cNvSpPr txBox="1"/>
           <p:nvPr/>
         </p:nvSpPr>
@@ -4342,45 +4492,6 @@
         <p:nvPr/>
       </p:nvGrpSpPr>
       <p:grpSpPr/>
-      <p:sp>
-        <p:nvSpPr>
-          <p:cNvPr id="2" name="TextBox 1"/>
-          <p:cNvSpPr txBox="1"/>
-          <p:nvPr/>
-        </p:nvSpPr>
-        <p:spPr>
-          <a:xfrm>
-            <a:off x="762000" y="571500"/>
-            <a:ext cx="10668000" cy="952500"/>
-          </a:xfrm>
-          <a:prstGeom prst="rect">
-            <a:avLst/>
-          </a:prstGeom>
-          <a:noFill/>
-        </p:spPr>
-        <p:txBody>
-          <a:bodyPr wrap="square">
-            <a:spAutoFit/>
-          </a:bodyPr>
-          <a:lstStyle/>
-          <a:p>
-            <a:pPr>
-              <a:spcAft>
-                <a:spcPts val="1800"/>
-              </a:spcAft>
-            </a:pPr>
-            <a:r>
-              <a:rPr sz="3000" b="1">
-                <a:solidFill>
-                  <a:srgbClr val="EEF2F7"/>
-                </a:solidFill>
-                <a:latin typeface="Cambria"/>
-              </a:rPr>
-              <a:t>Una línea sola es ruido; sumando miles, el error baja como 1/√N</a:t>
-            </a:r>
-          </a:p>
-        </p:txBody>
-      </p:sp>
       <p:pic>
         <p:nvPicPr>
           <p:cNvPr id="3" name="Picture 2" descr="static_lines.es.png"/>
@@ -4397,8 +4508,8 @@
         </p:blipFill>
         <p:spPr>
           <a:xfrm>
-            <a:off x="2144889" y="1714500"/>
-            <a:ext cx="7902222" cy="4445000"/>
+            <a:off x="0" y="0"/>
+            <a:ext cx="12192000" cy="6858000"/>
           </a:xfrm>
           <a:prstGeom prst="rect">
             <a:avLst/>
@@ -4408,6 +4519,108 @@
       <p:sp>
         <p:nvSpPr>
           <p:cNvPr id="4" name="TextBox 3"/>
+          <p:cNvSpPr txBox="1"/>
+          <p:nvPr/>
+        </p:nvSpPr>
+        <p:spPr>
+          <a:xfrm>
+            <a:off x="762000" y="444500"/>
+            <a:ext cx="10668000" cy="254000"/>
+          </a:xfrm>
+          <a:prstGeom prst="rect">
+            <a:avLst/>
+          </a:prstGeom>
+          <a:noFill/>
+        </p:spPr>
+        <p:txBody>
+          <a:bodyPr wrap="square">
+            <a:spAutoFit/>
+          </a:bodyPr>
+          <a:lstStyle/>
+          <a:p>
+            <a:pPr>
+              <a:spcAft>
+                <a:spcPts val="660"/>
+              </a:spcAft>
+            </a:pPr>
+            <a:r>
+              <a:rPr sz="1100" b="0">
+                <a:solidFill>
+                  <a:srgbClr val="F5A623"/>
+                </a:solidFill>
+                <a:latin typeface="Calibri"/>
+              </a:rPr>
+              <a:t>EL TRUCO</a:t>
+            </a:r>
+          </a:p>
+        </p:txBody>
+      </p:sp>
+      <p:sp>
+        <p:nvSpPr>
+          <p:cNvPr id="5" name="TextBox 4"/>
+          <p:cNvSpPr txBox="1"/>
+          <p:nvPr/>
+        </p:nvSpPr>
+        <p:spPr>
+          <a:xfrm>
+            <a:off x="762000" y="762000"/>
+            <a:ext cx="10668000" cy="952500"/>
+          </a:xfrm>
+          <a:prstGeom prst="rect">
+            <a:avLst/>
+          </a:prstGeom>
+          <a:noFill/>
+        </p:spPr>
+        <p:txBody>
+          <a:bodyPr wrap="square">
+            <a:spAutoFit/>
+          </a:bodyPr>
+          <a:lstStyle/>
+          <a:p>
+            <a:pPr>
+              <a:spcAft>
+                <a:spcPts val="1800"/>
+              </a:spcAft>
+            </a:pPr>
+            <a:r>
+              <a:rPr sz="3000" b="1">
+                <a:solidFill>
+                  <a:srgbClr val="EEF2F7"/>
+                </a:solidFill>
+                <a:latin typeface="Cambria"/>
+              </a:rPr>
+              <a:t>Una línea sola es ruido; sumando miles, el error baja como 1/√N</a:t>
+            </a:r>
+          </a:p>
+        </p:txBody>
+      </p:sp>
+      <p:sp>
+        <p:nvSpPr>
+          <p:cNvPr id="6" name="TextBox 5"/>
+          <p:cNvSpPr txBox="1"/>
+          <p:nvPr/>
+        </p:nvSpPr>
+        <p:spPr>
+          <a:xfrm>
+            <a:off x="762000" y="1714500"/>
+            <a:ext cx="10668000" cy="4445000"/>
+          </a:xfrm>
+          <a:prstGeom prst="rect">
+            <a:avLst/>
+          </a:prstGeom>
+          <a:noFill/>
+        </p:spPr>
+        <p:txBody>
+          <a:bodyPr wrap="square" anchor="ctr">
+            <a:spAutoFit/>
+          </a:bodyPr>
+          <a:lstStyle/>
+          <a:p/>
+        </p:txBody>
+      </p:sp>
+      <p:sp>
+        <p:nvSpPr>
+          <p:cNvPr id="7" name="TextBox 6"/>
           <p:cNvSpPr txBox="1"/>
           <p:nvPr/>
         </p:nvSpPr>
@@ -4478,7 +4691,46 @@
         </p:nvSpPr>
         <p:spPr>
           <a:xfrm>
-            <a:off x="762000" y="571500"/>
+            <a:off x="762000" y="444500"/>
+            <a:ext cx="10668000" cy="254000"/>
+          </a:xfrm>
+          <a:prstGeom prst="rect">
+            <a:avLst/>
+          </a:prstGeom>
+          <a:noFill/>
+        </p:spPr>
+        <p:txBody>
+          <a:bodyPr wrap="square">
+            <a:spAutoFit/>
+          </a:bodyPr>
+          <a:lstStyle/>
+          <a:p>
+            <a:pPr>
+              <a:spcAft>
+                <a:spcPts val="660"/>
+              </a:spcAft>
+            </a:pPr>
+            <a:r>
+              <a:rPr sz="1100" b="0">
+                <a:solidFill>
+                  <a:srgbClr val="F5A623"/>
+                </a:solidFill>
+                <a:latin typeface="Calibri"/>
+              </a:rPr>
+              <a:t>LO QUE SE MIDE</a:t>
+            </a:r>
+          </a:p>
+        </p:txBody>
+      </p:sp>
+      <p:sp>
+        <p:nvSpPr>
+          <p:cNvPr id="3" name="TextBox 2"/>
+          <p:cNvSpPr txBox="1"/>
+          <p:nvPr/>
+        </p:nvSpPr>
+        <p:spPr>
+          <a:xfrm>
+            <a:off x="762000" y="762000"/>
             <a:ext cx="10668000" cy="952500"/>
           </a:xfrm>
           <a:prstGeom prst="rect">
@@ -4511,7 +4763,7 @@
       </p:sp>
       <p:sp>
         <p:nvSpPr>
-          <p:cNvPr id="3" name="TextBox 2"/>
+          <p:cNvPr id="4" name="TextBox 3"/>
           <p:cNvSpPr txBox="1"/>
           <p:nvPr/>
         </p:nvSpPr>
@@ -4636,7 +4888,7 @@
       </p:sp>
       <p:sp>
         <p:nvSpPr>
-          <p:cNvPr id="4" name="TextBox 3"/>
+          <p:cNvPr id="5" name="TextBox 4"/>
           <p:cNvSpPr txBox="1"/>
           <p:nvPr/>
         </p:nvSpPr>
@@ -4699,45 +4951,6 @@
         <p:nvPr/>
       </p:nvGrpSpPr>
       <p:grpSpPr/>
-      <p:sp>
-        <p:nvSpPr>
-          <p:cNvPr id="2" name="TextBox 1"/>
-          <p:cNvSpPr txBox="1"/>
-          <p:nvPr/>
-        </p:nvSpPr>
-        <p:spPr>
-          <a:xfrm>
-            <a:off x="762000" y="571500"/>
-            <a:ext cx="10668000" cy="952500"/>
-          </a:xfrm>
-          <a:prstGeom prst="rect">
-            <a:avLst/>
-          </a:prstGeom>
-          <a:noFill/>
-        </p:spPr>
-        <p:txBody>
-          <a:bodyPr wrap="square">
-            <a:spAutoFit/>
-          </a:bodyPr>
-          <a:lstStyle/>
-          <a:p>
-            <a:pPr>
-              <a:spcAft>
-                <a:spcPts val="1800"/>
-              </a:spcAft>
-            </a:pPr>
-            <a:r>
-              <a:rPr sz="3000" b="1">
-                <a:solidFill>
-                  <a:srgbClr val="EEF2F7"/>
-                </a:solidFill>
-                <a:latin typeface="Cambria"/>
-              </a:rPr>
-              <a:t>Encontrar otra Tierra exige señales más de cien veces más chicas que las de un Júpiter</a:t>
-            </a:r>
-          </a:p>
-        </p:txBody>
-      </p:sp>
       <p:pic>
         <p:nvPicPr>
           <p:cNvPr id="3" name="Picture 2" descr="static_scale.es.png"/>
@@ -4754,8 +4967,8 @@
         </p:blipFill>
         <p:spPr>
           <a:xfrm>
-            <a:off x="2144889" y="1714500"/>
-            <a:ext cx="7902222" cy="4445000"/>
+            <a:off x="0" y="0"/>
+            <a:ext cx="12192000" cy="6858000"/>
           </a:xfrm>
           <a:prstGeom prst="rect">
             <a:avLst/>
@@ -4765,6 +4978,108 @@
       <p:sp>
         <p:nvSpPr>
           <p:cNvPr id="4" name="TextBox 3"/>
+          <p:cNvSpPr txBox="1"/>
+          <p:nvPr/>
+        </p:nvSpPr>
+        <p:spPr>
+          <a:xfrm>
+            <a:off x="762000" y="444500"/>
+            <a:ext cx="10668000" cy="254000"/>
+          </a:xfrm>
+          <a:prstGeom prst="rect">
+            <a:avLst/>
+          </a:prstGeom>
+          <a:noFill/>
+        </p:spPr>
+        <p:txBody>
+          <a:bodyPr wrap="square">
+            <a:spAutoFit/>
+          </a:bodyPr>
+          <a:lstStyle/>
+          <a:p>
+            <a:pPr>
+              <a:spcAft>
+                <a:spcPts val="660"/>
+              </a:spcAft>
+            </a:pPr>
+            <a:r>
+              <a:rPr sz="1100" b="0">
+                <a:solidFill>
+                  <a:srgbClr val="F5A623"/>
+                </a:solidFill>
+                <a:latin typeface="Calibri"/>
+              </a:rPr>
+              <a:t>LA ESCALA</a:t>
+            </a:r>
+          </a:p>
+        </p:txBody>
+      </p:sp>
+      <p:sp>
+        <p:nvSpPr>
+          <p:cNvPr id="5" name="TextBox 4"/>
+          <p:cNvSpPr txBox="1"/>
+          <p:nvPr/>
+        </p:nvSpPr>
+        <p:spPr>
+          <a:xfrm>
+            <a:off x="762000" y="762000"/>
+            <a:ext cx="10668000" cy="952500"/>
+          </a:xfrm>
+          <a:prstGeom prst="rect">
+            <a:avLst/>
+          </a:prstGeom>
+          <a:noFill/>
+        </p:spPr>
+        <p:txBody>
+          <a:bodyPr wrap="square">
+            <a:spAutoFit/>
+          </a:bodyPr>
+          <a:lstStyle/>
+          <a:p>
+            <a:pPr>
+              <a:spcAft>
+                <a:spcPts val="1800"/>
+              </a:spcAft>
+            </a:pPr>
+            <a:r>
+              <a:rPr sz="3000" b="1">
+                <a:solidFill>
+                  <a:srgbClr val="EEF2F7"/>
+                </a:solidFill>
+                <a:latin typeface="Cambria"/>
+              </a:rPr>
+              <a:t>Encontrar otra Tierra exige señales más de cien veces más chicas que las de un Júpiter</a:t>
+            </a:r>
+          </a:p>
+        </p:txBody>
+      </p:sp>
+      <p:sp>
+        <p:nvSpPr>
+          <p:cNvPr id="6" name="TextBox 5"/>
+          <p:cNvSpPr txBox="1"/>
+          <p:nvPr/>
+        </p:nvSpPr>
+        <p:spPr>
+          <a:xfrm>
+            <a:off x="762000" y="1714500"/>
+            <a:ext cx="10668000" cy="4445000"/>
+          </a:xfrm>
+          <a:prstGeom prst="rect">
+            <a:avLst/>
+          </a:prstGeom>
+          <a:noFill/>
+        </p:spPr>
+        <p:txBody>
+          <a:bodyPr wrap="square" anchor="ctr">
+            <a:spAutoFit/>
+          </a:bodyPr>
+          <a:lstStyle/>
+          <a:p/>
+        </p:txBody>
+      </p:sp>
+      <p:sp>
+        <p:nvSpPr>
+          <p:cNvPr id="7" name="TextBox 6"/>
           <p:cNvSpPr txBox="1"/>
           <p:nvPr/>
         </p:nvSpPr>
@@ -4835,7 +5150,46 @@
         </p:nvSpPr>
         <p:spPr>
           <a:xfrm>
-            <a:off x="762000" y="571500"/>
+            <a:off x="762000" y="444500"/>
+            <a:ext cx="10668000" cy="254000"/>
+          </a:xfrm>
+          <a:prstGeom prst="rect">
+            <a:avLst/>
+          </a:prstGeom>
+          <a:noFill/>
+        </p:spPr>
+        <p:txBody>
+          <a:bodyPr wrap="square">
+            <a:spAutoFit/>
+          </a:bodyPr>
+          <a:lstStyle/>
+          <a:p>
+            <a:pPr>
+              <a:spcAft>
+                <a:spcPts val="660"/>
+              </a:spcAft>
+            </a:pPr>
+            <a:r>
+              <a:rPr sz="1100" b="0">
+                <a:solidFill>
+                  <a:srgbClr val="F5A623"/>
+                </a:solidFill>
+                <a:latin typeface="Calibri"/>
+              </a:rPr>
+              <a:t>CÓMO SE HIZO</a:t>
+            </a:r>
+          </a:p>
+        </p:txBody>
+      </p:sp>
+      <p:sp>
+        <p:nvSpPr>
+          <p:cNvPr id="3" name="TextBox 2"/>
+          <p:cNvSpPr txBox="1"/>
+          <p:nvPr/>
+        </p:nvSpPr>
+        <p:spPr>
+          <a:xfrm>
+            <a:off x="762000" y="762000"/>
             <a:ext cx="10668000" cy="952500"/>
           </a:xfrm>
           <a:prstGeom prst="rect">
@@ -4868,7 +5222,7 @@
       </p:sp>
       <p:sp>
         <p:nvSpPr>
-          <p:cNvPr id="3" name="TextBox 2"/>
+          <p:cNvPr id="4" name="TextBox 3"/>
           <p:cNvSpPr txBox="1"/>
           <p:nvPr/>
         </p:nvSpPr>
@@ -4993,7 +5347,7 @@
       </p:sp>
       <p:sp>
         <p:nvSpPr>
-          <p:cNvPr id="4" name="TextBox 3"/>
+          <p:cNvPr id="5" name="TextBox 4"/>
           <p:cNvSpPr txBox="1"/>
           <p:nvPr/>
         </p:nvSpPr>

</xml_diff>